<commit_message>
Clarify unified NodeArticle workflow
</commit_message>
<xml_diff>
--- a/docs/presentations/NodeArticle_경쟁서비스_차별성분석.pptx
+++ b/docs/presentations/NodeArticle_경쟁서비스_차별성분석.pptx
@@ -4561,8 +4561,8 @@
                 </a:solidFill>
                 <a:latin typeface="Malgun Gothic"/>
               </a:rPr>
-              <a:t>짧은 글은 자동화하고,
-긴 글은 구조화한다.</a:t>
+              <a:t>짧은 글은 빠르게 완성하고,
+긴 글은 같은 공간에서 계속 구조화한다.</a:t>
             </a:r>
           </a:p>
         </p:txBody>
@@ -4809,7 +4809,7 @@
                 </a:solidFill>
                 <a:latin typeface="Malgun Gothic"/>
               </a:rPr>
-              <a:t>하나의 서비스, 두 가지 글쓰기 모드</a:t>
+              <a:t>하나의 인터페이스, 글의 복잡도에 따라 깊어지는 워크플로</a:t>
             </a:r>
           </a:p>
         </p:txBody>
@@ -4844,7 +4844,7 @@
                 </a:solidFill>
                 <a:latin typeface="Malgun Gothic"/>
               </a:rPr>
-              <a:t>기사의 길이와 복잡도에 따라 AI의 역할이 달라진다.</a:t>
+              <a:t>별도 모드 전환 없이 같은 편집 환경에서 필요한 단계까지 사용한다.</a:t>
             </a:r>
           </a:p>
         </p:txBody>
@@ -4924,7 +4924,7 @@
                 </a:solidFill>
                 <a:latin typeface="Malgun Gothic"/>
               </a:rPr>
-              <a:t>FAST / 짧은 기사</a:t>
+              <a:t>짧은 기사 / 빠른 종료</a:t>
             </a:r>
           </a:p>
         </p:txBody>
@@ -5043,7 +5043,7 @@
                 </a:solidFill>
                 <a:latin typeface="Malgun Gothic"/>
               </a:rPr>
-              <a:t>DEEP / 특집·기획</a:t>
+              <a:t>긴 기사 / 계속 확장</a:t>
             </a:r>
           </a:p>
         </p:txBody>
@@ -5117,7 +5117,7 @@
                 </a:solidFill>
                 <a:latin typeface="Malgun Gothic"/>
               </a:rPr>
-              <a:t>자동화 중심</a:t>
+              <a:t>자동생성 후 빠른 검토·송고</a:t>
             </a:r>
           </a:p>
         </p:txBody>
@@ -5152,7 +5152,7 @@
                 </a:solidFill>
                 <a:latin typeface="Malgun Gothic"/>
               </a:rPr>
-              <a:t>정리·관리·검증 중심</a:t>
+              <a:t>같은 노드 그래프에서 정리·관리·검증</a:t>
             </a:r>
           </a:p>
         </p:txBody>

</xml_diff>